<commit_message>
Topics uploaded for Deferred and Supplementary Exams
</commit_message>
<xml_diff>
--- a/cits1003-lecture_slides/CITS1003-B ExamExample-exercises.pptx
+++ b/cits1003-lecture_slides/CITS1003-B ExamExample-exercises.pptx
@@ -4832,7 +4832,7 @@
           <a:p>
             <a:fld id="{6D6D7260-B7E4-B548-BD1F-84ED14536037}" type="datetimeFigureOut">
               <a:rPr lang="en-AU" smtClean="0"/>
-              <a:t>12/05/2025</a:t>
+              <a:t>3/06/2025</a:t>
             </a:fld>
             <a:endParaRPr lang="en-AU"/>
           </a:p>
@@ -11030,7 +11030,7 @@
           <a:p>
             <a:fld id="{88D38747-4367-4BD2-8D51-C97E202738E2}" type="datetime1">
               <a:rPr lang="en-US" smtClean="0"/>
-              <a:t>5/12/2025</a:t>
+              <a:t>6/3/2025</a:t>
             </a:fld>
             <a:endParaRPr lang="en-US" dirty="0"/>
           </a:p>
@@ -11335,7 +11335,7 @@
           <a:p>
             <a:fld id="{11F1B079-7EF0-44EE-B798-BCC497C9F3B2}" type="datetime1">
               <a:rPr lang="en-US" smtClean="0"/>
-              <a:t>5/12/2025</a:t>
+              <a:t>6/3/2025</a:t>
             </a:fld>
             <a:endParaRPr lang="en-US" dirty="0"/>
           </a:p>
@@ -11529,7 +11529,7 @@
           <a:p>
             <a:fld id="{28FF70A8-1D13-4657-95F0-A9EA54967B8D}" type="datetime1">
               <a:rPr lang="en-US" smtClean="0"/>
-              <a:t>5/12/2025</a:t>
+              <a:t>6/3/2025</a:t>
             </a:fld>
             <a:endParaRPr lang="en-US" dirty="0"/>
           </a:p>
@@ -11792,7 +11792,7 @@
           <a:p>
             <a:fld id="{21EB90AC-71BD-4C7F-8ACA-7B3F18292E63}" type="datetime1">
               <a:rPr lang="en-US" smtClean="0"/>
-              <a:t>5/12/2025</a:t>
+              <a:t>6/3/2025</a:t>
             </a:fld>
             <a:endParaRPr lang="en-US" dirty="0"/>
           </a:p>
@@ -12228,7 +12228,7 @@
           <a:p>
             <a:fld id="{4E6EFC2C-8905-46F0-B443-CE905B76BA01}" type="datetime1">
               <a:rPr lang="en-US" smtClean="0"/>
-              <a:t>5/12/2025</a:t>
+              <a:t>6/3/2025</a:t>
             </a:fld>
             <a:endParaRPr lang="en-US" dirty="0"/>
           </a:p>
@@ -12765,7 +12765,7 @@
           <a:p>
             <a:fld id="{D9079DC3-C9B5-499E-9140-0DC28B7074E2}" type="datetime1">
               <a:rPr lang="en-US" smtClean="0"/>
-              <a:t>5/12/2025</a:t>
+              <a:t>6/3/2025</a:t>
             </a:fld>
             <a:endParaRPr lang="en-US" dirty="0"/>
           </a:p>
@@ -13647,7 +13647,7 @@
           <a:p>
             <a:fld id="{30BB33EA-E472-4D22-9C03-A9C14AA21CED}" type="datetime1">
               <a:rPr lang="en-US" smtClean="0"/>
-              <a:t>5/12/2025</a:t>
+              <a:t>6/3/2025</a:t>
             </a:fld>
             <a:endParaRPr lang="en-US" dirty="0"/>
           </a:p>
@@ -13817,7 +13817,7 @@
           <a:p>
             <a:fld id="{217E833E-1B6D-415F-AD29-75AE8C43BD0D}" type="datetime1">
               <a:rPr lang="en-US" smtClean="0"/>
-              <a:t>5/12/2025</a:t>
+              <a:t>6/3/2025</a:t>
             </a:fld>
             <a:endParaRPr lang="en-US" dirty="0"/>
           </a:p>
@@ -14001,7 +14001,7 @@
           <a:p>
             <a:fld id="{8452596F-08A7-4B70-989A-F2B1CF31E66B}" type="datetime1">
               <a:rPr lang="en-US" smtClean="0"/>
-              <a:t>5/12/2025</a:t>
+              <a:t>6/3/2025</a:t>
             </a:fld>
             <a:endParaRPr lang="en-US" dirty="0"/>
           </a:p>
@@ -14171,7 +14171,7 @@
           <a:p>
             <a:fld id="{73C55A3C-5767-4844-A0A3-83778C2E5409}" type="datetime1">
               <a:rPr lang="en-US" smtClean="0"/>
-              <a:t>5/12/2025</a:t>
+              <a:t>6/3/2025</a:t>
             </a:fld>
             <a:endParaRPr lang="en-US" dirty="0"/>
           </a:p>
@@ -14415,7 +14415,7 @@
           <a:p>
             <a:fld id="{CAE507A8-A5CF-4D38-AB86-7EDDA87A85D4}" type="datetime1">
               <a:rPr lang="en-US" smtClean="0"/>
-              <a:t>5/12/2025</a:t>
+              <a:t>6/3/2025</a:t>
             </a:fld>
             <a:endParaRPr lang="en-US" dirty="0"/>
           </a:p>
@@ -14657,7 +14657,7 @@
           <a:p>
             <a:fld id="{BDFCD27C-8599-43EF-BA1D-14DDC1946E06}" type="datetime1">
               <a:rPr lang="en-US" smtClean="0"/>
-              <a:t>5/12/2025</a:t>
+              <a:t>6/3/2025</a:t>
             </a:fld>
             <a:endParaRPr lang="en-US" dirty="0"/>
           </a:p>
@@ -15138,7 +15138,7 @@
           <a:p>
             <a:fld id="{49343D99-809A-49C0-96E5-4250D0B498EE}" type="datetime1">
               <a:rPr lang="en-US" smtClean="0"/>
-              <a:t>5/12/2025</a:t>
+              <a:t>6/3/2025</a:t>
             </a:fld>
             <a:endParaRPr lang="en-US" dirty="0"/>
           </a:p>
@@ -15256,7 +15256,7 @@
           <a:p>
             <a:fld id="{A143DE9B-B678-4EFB-BB7D-A4370204A0B0}" type="datetime1">
               <a:rPr lang="en-US" smtClean="0"/>
-              <a:t>5/12/2025</a:t>
+              <a:t>6/3/2025</a:t>
             </a:fld>
             <a:endParaRPr lang="en-US" dirty="0"/>
           </a:p>
@@ -15351,7 +15351,7 @@
           <a:p>
             <a:fld id="{E68812DA-F765-4142-A6A3-A8ED7235E082}" type="datetime1">
               <a:rPr lang="en-US" smtClean="0"/>
-              <a:t>5/12/2025</a:t>
+              <a:t>6/3/2025</a:t>
             </a:fld>
             <a:endParaRPr lang="en-US" dirty="0"/>
           </a:p>
@@ -15606,7 +15606,7 @@
           <a:p>
             <a:fld id="{3E0277FD-7DE6-41D4-930D-AC99F5AFE54E}" type="datetime1">
               <a:rPr lang="en-US" smtClean="0"/>
-              <a:t>5/12/2025</a:t>
+              <a:t>6/3/2025</a:t>
             </a:fld>
             <a:endParaRPr lang="en-US" dirty="0"/>
           </a:p>
@@ -15913,7 +15913,7 @@
           <a:p>
             <a:fld id="{9EA15526-7079-4B7B-987C-1B5FAE11A0FF}" type="datetime1">
               <a:rPr lang="en-US" smtClean="0"/>
-              <a:t>5/12/2025</a:t>
+              <a:t>6/3/2025</a:t>
             </a:fld>
             <a:endParaRPr lang="en-US" dirty="0"/>
           </a:p>
@@ -16148,7 +16148,7 @@
           <a:p>
             <a:fld id="{073ED0CC-082F-4160-86E5-0D6041F12778}" type="datetime1">
               <a:rPr lang="en-US" smtClean="0"/>
-              <a:t>5/12/2025</a:t>
+              <a:t>6/3/2025</a:t>
             </a:fld>
             <a:endParaRPr lang="en-US" dirty="0"/>
           </a:p>
@@ -17059,7 +17059,7 @@
           </a:effectLst>
           <a:extLst>
             <a:ext uri="{91240B29-F687-4f45-9708-019B960494DF}">
-              <a14:hiddenLine xmlns:a16="http://schemas.microsoft.com/office/drawing/2014/main" xmlns:p14="http://schemas.microsoft.com/office/powerpoint/2010/main" xmlns:a14="http://schemas.microsoft.com/office/drawing/2010/main" xmlns="" w="9525">
+              <a14:hiddenLine xmlns="" xmlns:a14="http://schemas.microsoft.com/office/drawing/2010/main" xmlns:p14="http://schemas.microsoft.com/office/powerpoint/2010/main" xmlns:a16="http://schemas.microsoft.com/office/drawing/2014/main" w="9525">
                 <a:solidFill>
                   <a:srgbClr val="000000"/>
                 </a:solidFill>
@@ -33488,7 +33488,7 @@
         </p:nvSpPr>
         <p:spPr>
           <a:xfrm>
-            <a:off x="729933" y="-1287"/>
+            <a:off x="771497" y="83128"/>
             <a:ext cx="10353762" cy="843396"/>
           </a:xfrm>
         </p:spPr>
@@ -33506,21 +33506,33 @@
                   <a:srgbClr val="FF0000"/>
                 </a:solidFill>
               </a:rPr>
-              <a:t>Deferred</a:t>
-            </a:r>
-            <a:r>
-              <a:rPr lang="en-AU" dirty="0"/>
-              <a:t>)</a:t>
-            </a:r>
-          </a:p>
-        </p:txBody>
-      </p:sp>
-      <p:sp>
-        <p:nvSpPr>
-          <p:cNvPr id="3" name="Content Placeholder 2">
+              <a:t>Deferred </a:t>
+            </a:r>
+            <a:r>
+              <a:rPr lang="en-US" altLang="zh-CN" dirty="0">
+                <a:solidFill>
+                  <a:srgbClr val="FF0000"/>
+                </a:solidFill>
+              </a:rPr>
+              <a:t>and </a:t>
+            </a:r>
+            <a:r>
+              <a:rPr lang="en-AU" dirty="0">
+                <a:solidFill>
+                  <a:srgbClr val="FF0000"/>
+                </a:solidFill>
+              </a:rPr>
+              <a:t>Supplementary)</a:t>
+            </a:r>
+          </a:p>
+        </p:txBody>
+      </p:sp>
+      <p:sp>
+        <p:nvSpPr>
+          <p:cNvPr id="6" name="Content Placeholder 2">
             <a:extLst>
               <a:ext uri="{FF2B5EF4-FFF2-40B4-BE49-F238E27FC236}">
-                <a16:creationId xmlns:a16="http://schemas.microsoft.com/office/drawing/2014/main" id="{F7DD7DCB-C7E2-1B4F-BD83-3B7AF005DD76}"/>
+                <a16:creationId xmlns:a16="http://schemas.microsoft.com/office/drawing/2014/main" id="{4A7CF194-541E-4126-8B22-6C7A8E21C122}"/>
               </a:ext>
             </a:extLst>
           </p:cNvPr>
@@ -33533,7 +33545,7 @@
         </p:nvSpPr>
         <p:spPr>
           <a:xfrm>
-            <a:off x="186512" y="936702"/>
+            <a:off x="186512" y="1153036"/>
             <a:ext cx="11818975" cy="5374888"/>
           </a:xfrm>
         </p:spPr>
@@ -33544,8 +33556,98 @@
           <a:lstStyle/>
           <a:p>
             <a:r>
-              <a:rPr lang="en-AU" sz="2600" dirty="0"/>
-              <a:t>TBA</a:t>
+              <a:rPr lang="en-AU" sz="2400" dirty="0"/>
+              <a:t>7 themed questions in 6 topics (100 marks)</a:t>
+            </a:r>
+          </a:p>
+          <a:p>
+            <a:pPr lvl="1"/>
+            <a:r>
+              <a:rPr lang="en-AU" sz="2400" dirty="0"/>
+              <a:t>AI in cybersecurity (live-lecture)</a:t>
+            </a:r>
+          </a:p>
+          <a:p>
+            <a:pPr lvl="1"/>
+            <a:r>
+              <a:rPr lang="en-AU" sz="2400" dirty="0"/>
+              <a:t>Cyber concepts in </a:t>
+            </a:r>
+            <a:r>
+              <a:rPr lang="en-AU" sz="2400" b="1" dirty="0"/>
+              <a:t>Week1’s</a:t>
+            </a:r>
+            <a:r>
+              <a:rPr lang="zh-CN" altLang="en-US" sz="2400" b="1" dirty="0"/>
+              <a:t> </a:t>
+            </a:r>
+            <a:r>
+              <a:rPr lang="en-AU" altLang="zh-CN" sz="2400" b="1" dirty="0"/>
+              <a:t>live</a:t>
+            </a:r>
+            <a:r>
+              <a:rPr lang="zh-CN" altLang="en-US" sz="2400" b="1" dirty="0"/>
+              <a:t> </a:t>
+            </a:r>
+            <a:r>
+              <a:rPr lang="en-AU" altLang="zh-CN" sz="2400" b="1" dirty="0"/>
+              <a:t>lecture</a:t>
+            </a:r>
+            <a:r>
+              <a:rPr lang="en-AU" sz="2400" b="1" dirty="0"/>
+              <a:t> </a:t>
+            </a:r>
+            <a:r>
+              <a:rPr lang="en-AU" sz="2400" dirty="0"/>
+              <a:t>with a Linux command from </a:t>
+            </a:r>
+            <a:r>
+              <a:rPr lang="en-AU" sz="2400" b="1" dirty="0"/>
+              <a:t>S</a:t>
+            </a:r>
+            <a:r>
+              <a:rPr lang="en-US" altLang="zh-CN" sz="2400" b="1" dirty="0"/>
+              <a:t>ection1.3 in</a:t>
+            </a:r>
+            <a:r>
+              <a:rPr lang="en-AU" sz="2400" b="1" dirty="0"/>
+              <a:t> Lab3</a:t>
+            </a:r>
+            <a:r>
+              <a:rPr lang="en-AU" sz="2400" dirty="0"/>
+              <a:t> </a:t>
+            </a:r>
+          </a:p>
+          <a:p>
+            <a:pPr lvl="1"/>
+            <a:r>
+              <a:rPr lang="en-AU" sz="2400" dirty="0"/>
+              <a:t>Cryptography (pre-recorded videos and live-lecture)</a:t>
+            </a:r>
+          </a:p>
+          <a:p>
+            <a:pPr lvl="1"/>
+            <a:r>
+              <a:rPr lang="en-AU" sz="2400" dirty="0"/>
+              <a:t>Threats (live-lecture)</a:t>
+            </a:r>
+          </a:p>
+          <a:p>
+            <a:pPr lvl="1"/>
+            <a:r>
+              <a:rPr lang="en-AU" sz="2400" dirty="0"/>
+              <a:t>Vulnerabilities (pre-recorded videos and live-lecture), with a Linux command from </a:t>
+            </a:r>
+            <a:r>
+              <a:rPr lang="en-AU" sz="2400" b="1" dirty="0"/>
+              <a:t>Sections 2-3 in Lab4</a:t>
+            </a:r>
+          </a:p>
+          <a:p>
+            <a:pPr lvl="1"/>
+            <a:r>
+              <a:rPr lang="en-AU" sz="2400" dirty="0"/>
+              <a:t>Incidents (live-lecture)</a:t>
             </a:r>
           </a:p>
         </p:txBody>

</xml_diff>